<commit_message>
format_qa 버그 수정 + body_desc 서식 보존 수정
format_qa.py:
  - txBody 검색 NS_A → NS_P 수정 (NS_A로 찾으면 항상 None → shape 전체 스킵)
  - 실제 비교 기능 정상화

ppt_generator.py _apply_common_zones._set_shape:
  - sz 무조건 삭제 제거 → 원본 명시 크기(sz) 보존
  - orig_rPr=None 시 force_semibold인 경우만 폰트 강제 생성
    (일반 shape는 rPr 없으면 그대로 테마 상속 유지)
  결과: body_desc sz=12pt 보존, subtitle 테마 상속 폰트 유지

Co-Authored-By: Claude Sonnet 4.6 <noreply@anthropic.com>
</commit_message>
<xml_diff>
--- a/result/머신러닝_심층_기술_가이드_재현검증.pptx
+++ b/result/머신러닝_심층_기술_가이드_재현검증.pptx
@@ -3303,11 +3303,6 @@
           <ns1:lstStyle/>
           <ns1:p>
             <ns1:r>
-              <ns1:rPr dirty="0">
-                <ns1:latin typeface="Pretendard"/>
-                <ns1:ea typeface="Pretendard"/>
-                <ns1:cs typeface="Pretendard"/>
-              </ns1:rPr>
               <ns1:t>05 프레임워크 선택</ns1:t>
             </ns1:r>
           </ns1:p>
@@ -3400,7 +3395,7 @@
           <ns1:lstStyle/>
           <ns1:p>
             <ns1:r>
-              <ns1:rPr lang="ko-KR" altLang="en-US" dirty="0" smtClean="0">
+              <ns1:rPr lang="ko-KR" altLang="en-US" sz="1200" dirty="0" smtClean="0">
                 <ns1:solidFill>
                   <ns1:schemeClr val="tx1">
                     <ns1:lumMod val="75000"/>
@@ -5110,11 +5105,6 @@
           <ns1:lstStyle/>
           <ns1:p>
             <ns1:r>
-              <ns1:rPr dirty="0">
-                <ns1:latin typeface="Pretendard"/>
-                <ns1:ea typeface="Pretendard"/>
-                <ns1:cs typeface="Pretendard"/>
-              </ns1:rPr>
               <ns1:t>07 ML Ops</ns1:t>
             </ns1:r>
           </ns1:p>
@@ -5218,7 +5208,7 @@
           <ns1:lstStyle/>
           <ns1:p>
             <ns1:r>
-              <ns1:rPr lang="ko-KR" altLang="en-US" dirty="0" smtClean="0">
+              <ns1:rPr lang="ko-KR" altLang="en-US" sz="1200" dirty="0" smtClean="0">
                 <ns1:solidFill>
                   <ns1:schemeClr val="tx1">
                     <ns1:lumMod val="75000"/>
@@ -8494,11 +8484,6 @@
           <ns1:lstStyle/>
           <ns1:p>
             <ns1:r>
-              <ns1:rPr dirty="0">
-                <ns1:latin typeface="Pretendard"/>
-                <ns1:ea typeface="Pretendard"/>
-                <ns1:cs typeface="Pretendard"/>
-              </ns1:rPr>
               <ns1:t>11 핵심 역량</ns1:t>
             </ns1:r>
           </ns1:p>
@@ -8591,7 +8576,7 @@
           <ns1:lstStyle/>
           <ns1:p>
             <ns1:r>
-              <ns1:rPr lang="ko-KR" altLang="en-US" dirty="0" smtClean="0">
+              <ns1:rPr lang="ko-KR" altLang="en-US" sz="1200" dirty="0" smtClean="0">
                 <ns1:solidFill>
                   <ns1:schemeClr val="tx1">
                     <ns1:lumMod val="75000"/>
@@ -14308,7 +14293,7 @@
           <ns1:lstStyle/>
           <ns1:p>
             <ns1:r>
-              <ns1:rPr lang="ko-KR" dirty="0">
+              <ns1:rPr lang="ko-KR" dirty="0" sz="1200">
                 <ns1:latin typeface="Pretendard"/>
                 <ns1:ea typeface="Pretendard"/>
                 <ns1:cs typeface="Pretendard"/>
@@ -15620,11 +15605,6 @@
           <ns1:lstStyle/>
           <ns1:p>
             <ns1:r>
-              <ns1:rPr dirty="0">
-                <ns1:latin typeface="Pretendard"/>
-                <ns1:ea typeface="Pretendard"/>
-                <ns1:cs typeface="Pretendard"/>
-              </ns1:rPr>
               <ns1:t>10 ML 서비스</ns1:t>
             </ns1:r>
           </ns1:p>
@@ -15920,11 +15900,6 @@
           <ns1:lstStyle/>
           <ns1:p>
             <ns1:r>
-              <ns1:rPr dirty="0">
-                <ns1:latin typeface="Pretendard"/>
-                <ns1:ea typeface="Pretendard"/>
-                <ns1:cs typeface="Pretendard"/>
-              </ns1:rPr>
               <ns1:t>02 아키텍처 진화</ns1:t>
             </ns1:r>
           </ns1:p>
@@ -16243,7 +16218,7 @@
           <ns1:lstStyle/>
           <ns1:p>
             <ns1:r>
-              <ns1:rPr lang="ko-KR" altLang="en-US" dirty="0" smtClean="0">
+              <ns1:rPr lang="ko-KR" altLang="en-US" sz="1200" dirty="0" smtClean="0">
                 <ns1:solidFill>
                   <ns1:schemeClr val="tx1">
                     <ns1:lumMod val="75000"/>
@@ -17382,7 +17357,7 @@
           <ns1:lstStyle/>
           <ns1:p>
             <ns1:r>
-              <ns1:rPr lang="ko-KR" altLang="en-US" dirty="0">
+              <ns1:rPr lang="ko-KR" altLang="en-US" sz="1200" dirty="0">
                 <ns1:solidFill>
                   <ns1:schemeClr val="tx1">
                     <ns1:lumMod val="75000"/>
@@ -23432,11 +23407,6 @@
           <ns1:lstStyle/>
           <ns1:p>
             <ns1:r>
-              <ns1:rPr dirty="0">
-                <ns1:latin typeface="Pretendard"/>
-                <ns1:ea typeface="Pretendard"/>
-                <ns1:cs typeface="Pretendard"/>
-              </ns1:rPr>
               <ns1:t>03 데이터 파이프라인</ns1:t>
             </ns1:r>
           </ns1:p>
@@ -23529,7 +23499,7 @@
           <ns1:lstStyle/>
           <ns1:p>
             <ns1:r>
-              <ns1:rPr lang="ko-KR" altLang="en-US" dirty="0" smtClean="0">
+              <ns1:rPr lang="ko-KR" altLang="en-US" sz="1200" dirty="0" smtClean="0">
                 <ns1:solidFill>
                   <ns1:schemeClr val="tx1">
                     <ns1:lumMod val="75000"/>

</xml_diff>